<commit_message>
Atualiza board com fluxo de 16-04
</commit_message>
<xml_diff>
--- a/Board_Integrado_Auto.pptx
+++ b/Board_Integrado_Auto.pptx
@@ -2457,12 +2457,12 @@
             <a:r>
               <a:rPr lang="pt-BR" sz="2600" b="1">
                 <a:solidFill>
-                  <a:srgbClr val="AF3527"/>
-                </a:solidFill>
-                <a:latin typeface="Aptos"/>
-                <a:cs typeface="Aptos"/>
-              </a:rPr>
-              <a:t>-R$ 228.939,78</a:t>
+                  <a:srgbClr val="2F7F4F"/>
+                </a:solidFill>
+                <a:latin typeface="Aptos"/>
+                <a:cs typeface="Aptos"/>
+              </a:rPr>
+              <a:t>R$ 4.175.321,05</a:t>
             </a:r>
             <a:endParaRPr lang="pt-BR" sz="2600"/>
           </a:p>
@@ -2518,7 +2518,7 @@
                 <a:latin typeface="Aptos"/>
                 <a:cs typeface="Aptos"/>
               </a:rPr>
-              <a:t>R$ 15.906.299,46</a:t>
+              <a:t>R$ 4.485.615,95</a:t>
             </a:r>
             <a:endParaRPr lang="pt-BR" sz="2400"/>
           </a:p>
@@ -2574,7 +2574,7 @@
                 <a:latin typeface="Aptos"/>
                 <a:cs typeface="Aptos"/>
               </a:rPr>
-              <a:t>R$ 0,00</a:t>
+              <a:t>R$ 35.092.450,33</a:t>
             </a:r>
             <a:endParaRPr lang="pt-BR" sz="2400"/>
           </a:p>
@@ -2842,12 +2842,12 @@
             <a:r>
               <a:rPr lang="pt-BR" sz="2700" b="1">
                 <a:solidFill>
-                  <a:srgbClr val="AF3527"/>
-                </a:solidFill>
-                <a:latin typeface="Aptos"/>
-                <a:cs typeface="Aptos"/>
-              </a:rPr>
-              <a:t>-R$ 228.939,78</a:t>
+                  <a:srgbClr val="2F7F4F"/>
+                </a:solidFill>
+                <a:latin typeface="Aptos"/>
+                <a:cs typeface="Aptos"/>
+              </a:rPr>
+              <a:t>R$ 4.175.321,05</a:t>
             </a:r>
             <a:endParaRPr lang="pt-BR" sz="2700"/>
           </a:p>
@@ -3033,7 +3033,7 @@
                 <a:latin typeface="Aptos"/>
                 <a:cs typeface="Aptos"/>
               </a:rPr>
-              <a:t>O caixa imediato está em -228,939.78 e o acumulado do ano em -1,110,611.47.</a:t>
+              <a:t>O caixa imediato está em 4,175,321.05 e o acumulado do ano em -1,110,611.47.</a:t>
             </a:r>
             <a:endParaRPr lang="pt-BR" sz="1550"/>
           </a:p>
@@ -3266,7 +3266,7 @@
                 <a:latin typeface="Aptos"/>
                 <a:cs typeface="Aptos"/>
               </a:rPr>
-              <a:t>R$ 15.906.299,46</a:t>
+              <a:t>R$ 4.485.615,95</a:t>
             </a:r>
             <a:endParaRPr lang="pt-BR" sz="2500"/>
           </a:p>
@@ -3322,7 +3322,7 @@
                 <a:latin typeface="Aptos"/>
                 <a:cs typeface="Aptos"/>
               </a:rPr>
-              <a:t>R$ 0,00</a:t>
+              <a:t>R$ 35.092.450,33</a:t>
             </a:r>
             <a:endParaRPr lang="pt-BR" sz="2500"/>
           </a:p>

</xml_diff>